<commit_message>
Fix slide 9 conceptual model: horizontal arrows only (PowerPoint drops upward line geometry)
Co-Authored-By: Claude Opus 4.8 (1M context) <noreply@anthropic.com>
</commit_message>
<xml_diff>
--- a/files/Danone_Presentation_rev3.pptx
+++ b/files/Danone_Presentation_rev3.pptx
@@ -19678,8 +19678,8 @@
         </p:nvSpPr>
         <p:spPr>
           <a:xfrm>
-            <a:off x="4114800" y="2203704"/>
-            <a:ext cx="777240" cy="1536192"/>
+            <a:off x="4160520" y="2203704"/>
+            <a:ext cx="731520" cy="0"/>
           </a:xfrm>
           <a:prstGeom prst="line">
             <a:avLst/>
@@ -19832,8 +19832,8 @@
         </p:nvSpPr>
         <p:spPr>
           <a:xfrm>
-            <a:off x="4114800" y="2971800"/>
-            <a:ext cx="777240" cy="768096"/>
+            <a:off x="4160520" y="2971800"/>
+            <a:ext cx="731520" cy="0"/>
           </a:xfrm>
           <a:prstGeom prst="line">
             <a:avLst/>
@@ -19986,8 +19986,8 @@
         </p:nvSpPr>
         <p:spPr>
           <a:xfrm>
-            <a:off x="4114800" y="3739896"/>
-            <a:ext cx="777240" cy="0"/>
+            <a:off x="4160520" y="3739896"/>
+            <a:ext cx="731520" cy="0"/>
           </a:xfrm>
           <a:prstGeom prst="line">
             <a:avLst/>
@@ -20140,8 +20140,8 @@
         </p:nvSpPr>
         <p:spPr>
           <a:xfrm>
-            <a:off x="4114800" y="4507992"/>
-            <a:ext cx="777240" cy="-768096"/>
+            <a:off x="4160520" y="4507992"/>
+            <a:ext cx="731520" cy="0"/>
           </a:xfrm>
           <a:prstGeom prst="line">
             <a:avLst/>
@@ -20294,8 +20294,8 @@
         </p:nvSpPr>
         <p:spPr>
           <a:xfrm>
-            <a:off x="4114800" y="5276088"/>
-            <a:ext cx="777240" cy="-1536192"/>
+            <a:off x="4160520" y="5276088"/>
+            <a:ext cx="731520" cy="0"/>
           </a:xfrm>
           <a:prstGeom prst="line">
             <a:avLst/>
@@ -20318,8 +20318,8 @@
         </p:nvSpPr>
         <p:spPr>
           <a:xfrm>
-            <a:off x="4983480" y="3063240"/>
-            <a:ext cx="3017520" cy="1371600"/>
+            <a:off x="4983480" y="1874520"/>
+            <a:ext cx="2697480" cy="3730752"/>
           </a:xfrm>
           <a:prstGeom prst="rect">
             <a:avLst/>
@@ -20345,8 +20345,8 @@
         </p:nvSpPr>
         <p:spPr>
           <a:xfrm>
-            <a:off x="5074920" y="3200400"/>
-            <a:ext cx="2834640" cy="1097280"/>
+            <a:off x="5074920" y="1874520"/>
+            <a:ext cx="2514600" cy="3730752"/>
           </a:xfrm>
           <a:prstGeom prst="rect">
             <a:avLst/>
@@ -20362,7 +20362,7 @@
               <a:buNone/>
             </a:pPr>
             <a:r>
-              <a:rPr lang="en-US" sz="1600" b="1" dirty="0">
+              <a:rPr lang="en-US" sz="1800" b="1" dirty="0">
                 <a:solidFill>
                   <a:srgbClr val="FFFFFF"/>
                 </a:solidFill>
@@ -20370,9 +20370,43 @@
                 <a:ea typeface="Georgia" pitchFamily="34" charset="-122"/>
                 <a:cs typeface="Georgia" pitchFamily="34" charset="-120"/>
               </a:rPr>
-              <a:t>Consumer purchase decision</a:t>
-            </a:r>
-            <a:endParaRPr lang="en-US" sz="1600" dirty="0"/>
+              <a:t>Consumer</a:t>
+            </a:r>
+            <a:endParaRPr lang="en-US" sz="1800" dirty="0"/>
+          </a:p>
+          <a:p>
+            <a:pPr algn="ctr" indent="0" marL="0">
+              <a:buNone/>
+            </a:pPr>
+            <a:r>
+              <a:rPr lang="en-US" sz="1800" b="1" dirty="0">
+                <a:solidFill>
+                  <a:srgbClr val="FFFFFF"/>
+                </a:solidFill>
+                <a:latin typeface="Georgia" pitchFamily="34" charset="0"/>
+                <a:ea typeface="Georgia" pitchFamily="34" charset="-122"/>
+                <a:cs typeface="Georgia" pitchFamily="34" charset="-120"/>
+              </a:rPr>
+              <a:t>purchase</a:t>
+            </a:r>
+            <a:endParaRPr lang="en-US" sz="1800" dirty="0"/>
+          </a:p>
+          <a:p>
+            <a:pPr algn="ctr" indent="0" marL="0">
+              <a:buNone/>
+            </a:pPr>
+            <a:r>
+              <a:rPr lang="en-US" sz="1800" b="1" dirty="0">
+                <a:solidFill>
+                  <a:srgbClr val="FFFFFF"/>
+                </a:solidFill>
+                <a:latin typeface="Georgia" pitchFamily="34" charset="0"/>
+                <a:ea typeface="Georgia" pitchFamily="34" charset="-122"/>
+                <a:cs typeface="Georgia" pitchFamily="34" charset="-120"/>
+              </a:rPr>
+              <a:t>decision</a:t>
+            </a:r>
+            <a:endParaRPr lang="en-US" sz="1800" dirty="0"/>
           </a:p>
         </p:txBody>
       </p:sp>
@@ -20384,8 +20418,8 @@
         </p:nvSpPr>
         <p:spPr>
           <a:xfrm>
-            <a:off x="8001000" y="3401568"/>
-            <a:ext cx="685800" cy="-777240"/>
+            <a:off x="7772400" y="2651760"/>
+            <a:ext cx="868680" cy="0"/>
           </a:xfrm>
           <a:prstGeom prst="line">
             <a:avLst/>
@@ -20408,8 +20442,8 @@
         </p:nvSpPr>
         <p:spPr>
           <a:xfrm>
-            <a:off x="8001000" y="4096512"/>
-            <a:ext cx="685800" cy="777240"/>
+            <a:off x="7772400" y="4846320"/>
+            <a:ext cx="868680" cy="0"/>
           </a:xfrm>
           <a:prstGeom prst="line">
             <a:avLst/>

</xml_diff>

<commit_message>
Relabel conceptual model to course-native terms (independent/dependent variable); update presenter script card 9 with terms defense and fleet-investment answer
Co-Authored-By: Claude Opus 4.8 (1M context) <noreply@anthropic.com>
</commit_message>
<xml_diff>
--- a/files/Danone_Presentation_rev3.pptx
+++ b/files/Danone_Presentation_rev3.pptx
@@ -19664,7 +19664,7 @@
                 <a:ea typeface="Calibri" pitchFamily="34" charset="-122"/>
                 <a:cs typeface="Calibri" pitchFamily="34" charset="-120"/>
               </a:rPr>
-              <a:t>the variable under study</a:t>
+              <a:t>the independent variable under study</a:t>
             </a:r>
             <a:endParaRPr lang="en-US" sz="1000" dirty="0"/>
           </a:p>
@@ -19818,7 +19818,7 @@
                 <a:ea typeface="Calibri" pitchFamily="34" charset="-122"/>
                 <a:cs typeface="Calibri" pitchFamily="34" charset="-120"/>
               </a:rPr>
-              <a:t>control variable</a:t>
+              <a:t>other purchase driver we measure</a:t>
             </a:r>
             <a:endParaRPr lang="en-US" sz="1000" dirty="0"/>
           </a:p>
@@ -19972,7 +19972,7 @@
                 <a:ea typeface="Calibri" pitchFamily="34" charset="-122"/>
                 <a:cs typeface="Calibri" pitchFamily="34" charset="-120"/>
               </a:rPr>
-              <a:t>control variable</a:t>
+              <a:t>other purchase driver we measure</a:t>
             </a:r>
             <a:endParaRPr lang="en-US" sz="1000" dirty="0"/>
           </a:p>
@@ -20126,7 +20126,7 @@
                 <a:ea typeface="Calibri" pitchFamily="34" charset="-122"/>
                 <a:cs typeface="Calibri" pitchFamily="34" charset="-120"/>
               </a:rPr>
-              <a:t>moderator (H2, H3)</a:t>
+              <a:t>we split the results by it (H2, H3)</a:t>
             </a:r>
             <a:endParaRPr lang="en-US" sz="1000" dirty="0"/>
           </a:p>
@@ -20280,7 +20280,7 @@
                 <a:ea typeface="Calibri" pitchFamily="34" charset="-122"/>
                 <a:cs typeface="Calibri" pitchFamily="34" charset="-120"/>
               </a:rPr>
-              <a:t>moderator (H4)</a:t>
+              <a:t>we split the results by it (H4)</a:t>
             </a:r>
             <a:endParaRPr lang="en-US" sz="1000" dirty="0"/>
           </a:p>
@@ -20346,7 +20346,7 @@
         <p:spPr>
           <a:xfrm>
             <a:off x="5074920" y="1874520"/>
-            <a:ext cx="2514600" cy="3730752"/>
+            <a:ext cx="2514600" cy="3383280"/>
           </a:xfrm>
           <a:prstGeom prst="rect">
             <a:avLst/>
@@ -20412,7 +20412,46 @@
       </p:sp>
       <p:sp>
         <p:nvSpPr>
-          <p:cNvPr id="32" name="Shape 30"/>
+          <p:cNvPr id="32" name="Text 30"/>
+          <p:cNvSpPr/>
+          <p:nvPr/>
+        </p:nvSpPr>
+        <p:spPr>
+          <a:xfrm>
+            <a:off x="5074920" y="4983480"/>
+            <a:ext cx="2514600" cy="365760"/>
+          </a:xfrm>
+          <a:prstGeom prst="rect">
+            <a:avLst/>
+          </a:prstGeom>
+          <a:noFill/>
+          <a:ln/>
+        </p:spPr>
+        <p:txBody>
+          <a:bodyPr wrap="square" rtlCol="0" anchor="ctr"/>
+          <a:lstStyle/>
+          <a:p>
+            <a:pPr algn="ctr" indent="0" marL="0">
+              <a:buNone/>
+            </a:pPr>
+            <a:r>
+              <a:rPr lang="en-US" sz="1050" i="1" dirty="0">
+                <a:solidFill>
+                  <a:srgbClr val="8FB3D9"/>
+                </a:solidFill>
+                <a:latin typeface="Calibri" pitchFamily="34" charset="0"/>
+                <a:ea typeface="Calibri" pitchFamily="34" charset="-122"/>
+                <a:cs typeface="Calibri" pitchFamily="34" charset="-120"/>
+              </a:rPr>
+              <a:t>the dependent variable</a:t>
+            </a:r>
+            <a:endParaRPr lang="en-US" sz="1050" dirty="0"/>
+          </a:p>
+        </p:txBody>
+      </p:sp>
+      <p:sp>
+        <p:nvSpPr>
+          <p:cNvPr id="33" name="Shape 31"/>
           <p:cNvSpPr/>
           <p:nvPr/>
         </p:nvSpPr>
@@ -20436,7 +20475,7 @@
       </p:sp>
       <p:sp>
         <p:nvSpPr>
-          <p:cNvPr id="33" name="Shape 31"/>
+          <p:cNvPr id="34" name="Shape 32"/>
           <p:cNvSpPr/>
           <p:nvPr/>
         </p:nvSpPr>
@@ -20460,7 +20499,7 @@
       </p:sp>
       <p:sp>
         <p:nvSpPr>
-          <p:cNvPr id="34" name="Shape 32"/>
+          <p:cNvPr id="35" name="Shape 33"/>
           <p:cNvSpPr/>
           <p:nvPr/>
         </p:nvSpPr>
@@ -20492,7 +20531,7 @@
       </p:sp>
       <p:sp>
         <p:nvSpPr>
-          <p:cNvPr id="35" name="Shape 33"/>
+          <p:cNvPr id="36" name="Shape 34"/>
           <p:cNvSpPr/>
           <p:nvPr/>
         </p:nvSpPr>
@@ -20512,7 +20551,7 @@
       </p:sp>
       <p:sp>
         <p:nvSpPr>
-          <p:cNvPr id="36" name="Text 34"/>
+          <p:cNvPr id="37" name="Text 35"/>
           <p:cNvSpPr/>
           <p:nvPr/>
         </p:nvSpPr>
@@ -20551,7 +20590,7 @@
       </p:sp>
       <p:sp>
         <p:nvSpPr>
-          <p:cNvPr id="37" name="Text 35"/>
+          <p:cNvPr id="38" name="Text 36"/>
           <p:cNvSpPr/>
           <p:nvPr/>
         </p:nvSpPr>
@@ -20590,7 +20629,7 @@
       </p:sp>
       <p:sp>
         <p:nvSpPr>
-          <p:cNvPr id="38" name="Shape 36"/>
+          <p:cNvPr id="39" name="Shape 37"/>
           <p:cNvSpPr/>
           <p:nvPr/>
         </p:nvSpPr>
@@ -20622,7 +20661,7 @@
       </p:sp>
       <p:sp>
         <p:nvSpPr>
-          <p:cNvPr id="39" name="Shape 37"/>
+          <p:cNvPr id="40" name="Shape 38"/>
           <p:cNvSpPr/>
           <p:nvPr/>
         </p:nvSpPr>
@@ -20642,7 +20681,7 @@
       </p:sp>
       <p:sp>
         <p:nvSpPr>
-          <p:cNvPr id="40" name="Text 38"/>
+          <p:cNvPr id="41" name="Text 39"/>
           <p:cNvSpPr/>
           <p:nvPr/>
         </p:nvSpPr>
@@ -20681,7 +20720,7 @@
       </p:sp>
       <p:sp>
         <p:nvSpPr>
-          <p:cNvPr id="41" name="Text 39"/>
+          <p:cNvPr id="42" name="Text 40"/>
           <p:cNvSpPr/>
           <p:nvPr/>
         </p:nvSpPr>
@@ -20720,7 +20759,7 @@
       </p:sp>
       <p:sp>
         <p:nvSpPr>
-          <p:cNvPr id="42" name="Shape 40"/>
+          <p:cNvPr id="43" name="Shape 41"/>
           <p:cNvSpPr/>
           <p:nvPr/>
         </p:nvSpPr>
@@ -20745,7 +20784,7 @@
       </p:sp>
       <p:sp>
         <p:nvSpPr>
-          <p:cNvPr id="43" name="Text 41"/>
+          <p:cNvPr id="44" name="Text 42"/>
           <p:cNvSpPr/>
           <p:nvPr/>
         </p:nvSpPr>
@@ -20798,7 +20837,7 @@
       </p:sp>
       <p:sp>
         <p:nvSpPr>
-          <p:cNvPr id="44" name="Text 42"/>
+          <p:cNvPr id="45" name="Text 43"/>
           <p:cNvSpPr/>
           <p:nvPr/>
         </p:nvSpPr>
@@ -20837,7 +20876,7 @@
       </p:sp>
       <p:sp>
         <p:nvSpPr>
-          <p:cNvPr id="45" name="Text 43"/>
+          <p:cNvPr id="46" name="Text 44"/>
           <p:cNvSpPr/>
           <p:nvPr/>
         </p:nvSpPr>

</xml_diff>

<commit_message>
Chart data labels: force 2-decimal format (PowerPoint was rounding to integers); presenter notes: explain the 1-5 scale on cards 15-16
Co-Authored-By: Claude Opus 4.8 (1M context) <noreply@anthropic.com>
</commit_message>
<xml_diff>
--- a/files/Danone_Presentation_rev3.pptx
+++ b/files/Danone_Presentation_rev3.pptx
@@ -439,7 +439,7 @@
           </c:spPr>
           <c:invertIfNegative val="0"/>
           <c:dLbls>
-            <c:numFmt formatCode="#,##0" sourceLinked="0"/>
+            <c:numFmt formatCode="0.00" sourceLinked="0"/>
             <c:txPr>
               <a:bodyPr/>
               <a:lstStyle/>
@@ -519,7 +519,7 @@
           </c:val>
         </c:ser>
         <c:dLbls>
-          <c:numFmt formatCode="#,##0" sourceLinked="0"/>
+          <c:numFmt formatCode="0.00" sourceLinked="0"/>
           <c:txPr>
             <a:bodyPr/>
             <a:lstStyle/>
@@ -701,7 +701,7 @@
           </c:spPr>
           <c:invertIfNegative val="0"/>
           <c:dLbls>
-            <c:numFmt formatCode="#,##0" sourceLinked="0"/>
+            <c:numFmt formatCode="0.00" sourceLinked="0"/>
             <c:txPr>
               <a:bodyPr/>
               <a:lstStyle/>
@@ -796,7 +796,7 @@
           </c:val>
         </c:ser>
         <c:dLbls>
-          <c:numFmt formatCode="#,##0" sourceLinked="0"/>
+          <c:numFmt formatCode="0.00" sourceLinked="0"/>
           <c:txPr>
             <a:bodyPr/>
             <a:lstStyle/>

</xml_diff>